<commit_message>
Update CSE 4300 Presentation.pptx
</commit_message>
<xml_diff>
--- a/CSE4300/jesse-cindhy-ervin/CSE 4300 Presentation.pptx
+++ b/CSE4300/jesse-cindhy-ervin/CSE 4300 Presentation.pptx
@@ -18,9 +18,10 @@
     <p:sldId id="272" r:id="rId12"/>
     <p:sldId id="263" r:id="rId13"/>
     <p:sldId id="265" r:id="rId14"/>
-    <p:sldId id="266" r:id="rId15"/>
-    <p:sldId id="274" r:id="rId16"/>
-    <p:sldId id="267" r:id="rId17"/>
+    <p:sldId id="275" r:id="rId15"/>
+    <p:sldId id="266" r:id="rId16"/>
+    <p:sldId id="274" r:id="rId17"/>
+    <p:sldId id="267" r:id="rId18"/>
   </p:sldIdLst>
   <p:sldSz cx="12192000" cy="6858000"/>
   <p:notesSz cx="6858000" cy="9144000"/>
@@ -134,6 +135,7 @@
     <p1510:client id="{98D6B4C3-F205-4B21-CAC0-2BA6F4B42FF5}" v="505" dt="2025-11-14T22:40:07.281"/>
     <p1510:client id="{BDDC770B-235C-C280-658C-609093FD8C66}" v="50" dt="2025-11-15T18:55:43.534"/>
     <p1510:client id="{CD75B010-6D81-9006-2B71-1F424CD679A0}" v="732" dt="2025-11-16T01:29:18.919"/>
+    <p1510:client id="{F24710CC-1468-2C4D-87A7-A4C88340D298}" v="267" dt="2025-11-16T04:24:36.208"/>
     <p1510:client id="{F661D892-578D-A207-1227-C9A154798DFD}" v="32" dt="2025-11-15T17:00:43.007"/>
     <p1510:client id="{F7AB2033-F8D3-76E8-26EB-0D2BAD9A194F}" v="96" dt="2025-11-15T20:04:33.530"/>
   </p1510:revLst>
@@ -7115,7 +7117,7 @@
               </a:lnSpc>
             </a:pPr>
             <a:r>
-              <a:rPr lang="en-US" sz="900" dirty="0"/>
+              <a:rPr lang="en-US" sz="900"/>
               <a:t>CSE 4300</a:t>
             </a:r>
           </a:p>
@@ -7126,7 +7128,7 @@
               </a:lnSpc>
             </a:pPr>
             <a:r>
-              <a:rPr lang="en-US" sz="900" dirty="0"/>
+              <a:rPr lang="en-US" sz="900"/>
               <a:t>Jiawen Chen</a:t>
             </a:r>
           </a:p>
@@ -7137,7 +7139,7 @@
               </a:lnSpc>
             </a:pPr>
             <a:r>
-              <a:rPr lang="en-US" sz="900" dirty="0"/>
+              <a:rPr lang="en-US" sz="900"/>
               <a:t>Ervin Jimenez</a:t>
             </a:r>
           </a:p>
@@ -7148,7 +7150,7 @@
               </a:lnSpc>
             </a:pPr>
             <a:r>
-              <a:rPr lang="en-US" sz="900" dirty="0"/>
+              <a:rPr lang="en-US" sz="900"/>
               <a:t>Jesse Kuhns</a:t>
             </a:r>
           </a:p>
@@ -7270,7 +7272,7 @@
           <a:p>
             <a:pPr algn="ctr"/>
             <a:r>
-              <a:rPr lang="en-US" dirty="0"/>
+              <a:rPr lang="en-US"/>
               <a:t>Algorithm : SJF</a:t>
             </a:r>
           </a:p>
@@ -7402,7 +7404,7 @@
           <a:p>
             <a:pPr algn="ctr"/>
             <a:r>
-              <a:rPr lang="en-US" dirty="0"/>
+              <a:rPr lang="en-US"/>
               <a:t>Results</a:t>
             </a:r>
           </a:p>
@@ -7624,7 +7626,7 @@
           <a:lstStyle/>
           <a:p>
             <a:r>
-              <a:rPr lang="en-US" dirty="0"/>
+              <a:rPr lang="en-US"/>
               <a:t>Linux Kernel Implementation</a:t>
             </a:r>
           </a:p>
@@ -7658,7 +7660,7 @@
               <a:buChar char="-"/>
             </a:pPr>
             <a:r>
-              <a:rPr lang="en-US" dirty="0"/>
+              <a:rPr lang="en-US"/>
               <a:t>Requires thousands of lines of code</a:t>
             </a:r>
           </a:p>
@@ -7668,11 +7670,11 @@
               <a:buChar char="-"/>
             </a:pPr>
             <a:r>
-              <a:rPr lang="en-US" i="0" dirty="0" err="1"/>
+              <a:rPr lang="en-US" i="0" err="1"/>
               <a:t>rt.c</a:t>
             </a:r>
             <a:r>
-              <a:rPr lang="en-US" i="0" dirty="0"/>
+              <a:rPr lang="en-US" i="0"/>
               <a:t>, the scheduling class for just FIFO and RR, is 2,938 lines long</a:t>
             </a:r>
           </a:p>
@@ -7682,14 +7684,14 @@
               <a:buChar char="-"/>
             </a:pPr>
             <a:r>
-              <a:rPr lang="en-US" i="0" dirty="0" err="1"/>
+              <a:rPr lang="en-US" i="0" err="1"/>
               <a:t>sched.h</a:t>
             </a:r>
             <a:r>
-              <a:rPr lang="en-US" i="0" dirty="0"/>
+              <a:rPr lang="en-US" i="0"/>
               <a:t>, the header file for scheduler types and methods, is 3,903 lines</a:t>
             </a:r>
-            <a:endParaRPr lang="en-US" dirty="0"/>
+            <a:endParaRPr lang="en-US"/>
           </a:p>
           <a:p>
             <a:pPr>
@@ -7697,7 +7699,7 @@
               <a:buChar char="-"/>
             </a:pPr>
             <a:r>
-              <a:rPr lang="en-US" dirty="0"/>
+              <a:rPr lang="en-US"/>
               <a:t>Changes made directly to the kernel are very risky</a:t>
             </a:r>
           </a:p>
@@ -7707,7 +7709,7 @@
               <a:buChar char="-"/>
             </a:pPr>
             <a:r>
-              <a:rPr lang="en-US" dirty="0"/>
+              <a:rPr lang="en-US"/>
               <a:t>Work can be reduced by piggybacking off existing schedulers</a:t>
             </a:r>
           </a:p>
@@ -7717,7 +7719,7 @@
               <a:buChar char="-"/>
             </a:pPr>
             <a:r>
-              <a:rPr lang="en-US" dirty="0"/>
+              <a:rPr lang="en-US"/>
               <a:t>Still a mammoth undertaking!</a:t>
             </a:r>
           </a:p>
@@ -7727,7 +7729,7 @@
               <a:buChar char="-"/>
             </a:pPr>
             <a:r>
-              <a:rPr lang="en-US" dirty="0"/>
+              <a:rPr lang="en-US"/>
               <a:t>You need to know how it works to know what to take</a:t>
             </a:r>
           </a:p>
@@ -7768,7 +7770,7 @@
           <p:cNvPr id="2" name="Title 1">
             <a:extLst>
               <a:ext uri="{FF2B5EF4-FFF2-40B4-BE49-F238E27FC236}">
-                <a16:creationId xmlns:a16="http://schemas.microsoft.com/office/drawing/2014/main" id="{3292FFE8-8B7A-203E-0CE2-75A3B154F62B}"/>
+                <a16:creationId xmlns:a16="http://schemas.microsoft.com/office/drawing/2014/main" id="{A3E6FFE5-AFB0-8E1F-BAAC-23334C24F9A1}"/>
               </a:ext>
             </a:extLst>
           </p:cNvPr>
@@ -7785,12 +7787,8 @@
           <a:lstStyle/>
           <a:p>
             <a:r>
-              <a:rPr lang="en-US" dirty="0" err="1"/>
-              <a:t>eBPF</a:t>
-            </a:r>
-            <a:r>
-              <a:rPr lang="en-US" dirty="0"/>
-              <a:t> Implementation</a:t>
+              <a:rPr lang="en-US"/>
+              <a:t>Linux Kernel Implementation</a:t>
             </a:r>
           </a:p>
         </p:txBody>
@@ -7800,7 +7798,7 @@
           <p:cNvPr id="3" name="Content Placeholder 2">
             <a:extLst>
               <a:ext uri="{FF2B5EF4-FFF2-40B4-BE49-F238E27FC236}">
-                <a16:creationId xmlns:a16="http://schemas.microsoft.com/office/drawing/2014/main" id="{1F3359EA-326C-3165-B45D-27D56281BE2A}"/>
+                <a16:creationId xmlns:a16="http://schemas.microsoft.com/office/drawing/2014/main" id="{4BE96171-0F89-469B-EE82-CA89CFEB9DA4}"/>
               </a:ext>
             </a:extLst>
           </p:cNvPr>
@@ -7818,12 +7816,167 @@
           </a:bodyPr>
           <a:lstStyle/>
           <a:p>
+            <a:r>
+              <a:rPr lang="en-US"/>
+              <a:t>Requires changes to files in the kernel/sched/ directory, </a:t>
+            </a:r>
+          </a:p>
+          <a:p>
+            <a:r>
+              <a:rPr lang="en-US"/>
+              <a:t>Mainly, changes to </a:t>
+            </a:r>
+            <a:r>
+              <a:rPr lang="en-US" err="1"/>
+              <a:t>core.c</a:t>
+            </a:r>
+            <a:r>
+              <a:rPr lang="en-US"/>
+              <a:t>, </a:t>
+            </a:r>
+            <a:r>
+              <a:rPr lang="en-US" err="1"/>
+              <a:t>sched.h</a:t>
+            </a:r>
+            <a:r>
+              <a:rPr lang="en-US"/>
+              <a:t>, and </a:t>
+            </a:r>
+            <a:r>
+              <a:rPr lang="en-US" err="1"/>
+              <a:t>fair.c</a:t>
+            </a:r>
+            <a:r>
+              <a:rPr lang="en-US"/>
+              <a:t> </a:t>
+            </a:r>
+          </a:p>
+          <a:p>
+            <a:r>
+              <a:rPr lang="en-US"/>
+              <a:t>Status changes are made in </a:t>
+            </a:r>
+            <a:r>
+              <a:rPr lang="en-US" err="1"/>
+              <a:t>sched.h</a:t>
+            </a:r>
+            <a:r>
+              <a:rPr lang="en-US"/>
+              <a:t> in /include/</a:t>
+            </a:r>
+            <a:r>
+              <a:rPr lang="en-US" err="1"/>
+              <a:t>linux</a:t>
+            </a:r>
+            <a:r>
+              <a:rPr lang="en-US"/>
+              <a:t>/</a:t>
+            </a:r>
+            <a:r>
+              <a:rPr lang="en-US" err="1"/>
+              <a:t>sched.h</a:t>
+            </a:r>
+            <a:r>
+              <a:rPr lang="en-US"/>
+              <a:t> so that arrival time can be recorded for tasks marked as using the desired scheduling algorithm</a:t>
+            </a:r>
+          </a:p>
+          <a:p>
+            <a:endParaRPr lang="en-US"/>
+          </a:p>
+        </p:txBody>
+      </p:sp>
+    </p:spTree>
+    <p:extLst>
+      <p:ext uri="{BB962C8B-B14F-4D97-AF65-F5344CB8AC3E}">
+        <p14:creationId xmlns:p14="http://schemas.microsoft.com/office/powerpoint/2010/main" val="931649904"/>
+      </p:ext>
+    </p:extLst>
+  </p:cSld>
+  <p:clrMapOvr>
+    <a:masterClrMapping/>
+  </p:clrMapOvr>
+</p:sld>
+</file>
+
+<file path=ppt/slides/slide15.xml><?xml version="1.0" encoding="utf-8"?>
+<p:sld xmlns:a="http://schemas.openxmlformats.org/drawingml/2006/main" xmlns:r="http://schemas.openxmlformats.org/officeDocument/2006/relationships" xmlns:p="http://schemas.openxmlformats.org/presentationml/2006/main">
+  <p:cSld>
+    <p:spTree>
+      <p:nvGrpSpPr>
+        <p:cNvPr id="1" name=""/>
+        <p:cNvGrpSpPr/>
+        <p:nvPr/>
+      </p:nvGrpSpPr>
+      <p:grpSpPr>
+        <a:xfrm>
+          <a:off x="0" y="0"/>
+          <a:ext cx="0" cy="0"/>
+          <a:chOff x="0" y="0"/>
+          <a:chExt cx="0" cy="0"/>
+        </a:xfrm>
+      </p:grpSpPr>
+      <p:sp>
+        <p:nvSpPr>
+          <p:cNvPr id="2" name="Title 1">
+            <a:extLst>
+              <a:ext uri="{FF2B5EF4-FFF2-40B4-BE49-F238E27FC236}">
+                <a16:creationId xmlns:a16="http://schemas.microsoft.com/office/drawing/2014/main" id="{3292FFE8-8B7A-203E-0CE2-75A3B154F62B}"/>
+              </a:ext>
+            </a:extLst>
+          </p:cNvPr>
+          <p:cNvSpPr>
+            <a:spLocks noGrp="1"/>
+          </p:cNvSpPr>
+          <p:nvPr>
+            <p:ph type="title"/>
+          </p:nvPr>
+        </p:nvSpPr>
+        <p:spPr/>
+        <p:txBody>
+          <a:bodyPr/>
+          <a:lstStyle/>
+          <a:p>
+            <a:r>
+              <a:rPr lang="en-US" err="1"/>
+              <a:t>eBPF</a:t>
+            </a:r>
+            <a:r>
+              <a:rPr lang="en-US"/>
+              <a:t> Implementation</a:t>
+            </a:r>
+          </a:p>
+        </p:txBody>
+      </p:sp>
+      <p:sp>
+        <p:nvSpPr>
+          <p:cNvPr id="3" name="Content Placeholder 2">
+            <a:extLst>
+              <a:ext uri="{FF2B5EF4-FFF2-40B4-BE49-F238E27FC236}">
+                <a16:creationId xmlns:a16="http://schemas.microsoft.com/office/drawing/2014/main" id="{1F3359EA-326C-3165-B45D-27D56281BE2A}"/>
+              </a:ext>
+            </a:extLst>
+          </p:cNvPr>
+          <p:cNvSpPr>
+            <a:spLocks noGrp="1"/>
+          </p:cNvSpPr>
+          <p:nvPr>
+            <p:ph idx="1"/>
+          </p:nvPr>
+        </p:nvSpPr>
+        <p:spPr/>
+        <p:txBody>
+          <a:bodyPr vert="horz" lIns="91440" tIns="45720" rIns="91440" bIns="45720" rtlCol="0" anchor="t">
+            <a:normAutofit/>
+          </a:bodyPr>
+          <a:lstStyle/>
+          <a:p>
             <a:pPr>
               <a:buFont typeface="Calibri" panose="020B0604020202020204" pitchFamily="34" charset="0"/>
               <a:buChar char="-"/>
             </a:pPr>
             <a:r>
-              <a:rPr lang="en-US" dirty="0"/>
+              <a:rPr lang="en-US"/>
               <a:t>Significantly more straightforward</a:t>
             </a:r>
           </a:p>
@@ -7833,7 +7986,7 @@
               <a:buChar char="-"/>
             </a:pPr>
             <a:r>
-              <a:rPr lang="en-US" dirty="0"/>
+              <a:rPr lang="en-US"/>
               <a:t>Allows you to leverage existing infrastructure in a safer, easier way</a:t>
             </a:r>
           </a:p>
@@ -7843,18 +7996,18 @@
               <a:buChar char="-"/>
             </a:pPr>
             <a:r>
-              <a:rPr lang="en-US" dirty="0"/>
+              <a:rPr lang="en-US"/>
               <a:t>Extensible scheduler class (</a:t>
             </a:r>
             <a:r>
-              <a:rPr lang="en-US" dirty="0" err="1"/>
+              <a:rPr lang="en-US" err="1"/>
               <a:t>sched_ext</a:t>
             </a:r>
             <a:r>
-              <a:rPr lang="en-US" dirty="0"/>
+              <a:rPr lang="en-US"/>
               <a:t>)</a:t>
             </a:r>
-            <a:endParaRPr lang="en-US" i="0" dirty="0"/>
+            <a:endParaRPr lang="en-US" i="0"/>
           </a:p>
           <a:p>
             <a:pPr>
@@ -7862,7 +8015,7 @@
               <a:buChar char="-"/>
             </a:pPr>
             <a:r>
-              <a:rPr lang="en-US" dirty="0"/>
+              <a:rPr lang="en-US"/>
               <a:t>Schedulers can be written in dozens of lines of code, rather than thousands</a:t>
             </a:r>
           </a:p>
@@ -7872,7 +8025,7 @@
               <a:buChar char="-"/>
             </a:pPr>
             <a:r>
-              <a:rPr lang="en-US" dirty="0"/>
+              <a:rPr lang="en-US"/>
               <a:t>To use it, all you have to do is compile it with clang, and register it with the kernel</a:t>
             </a:r>
           </a:p>
@@ -7882,7 +8035,7 @@
               <a:buChar char="-"/>
             </a:pPr>
             <a:r>
-              <a:rPr lang="en-US" dirty="0"/>
+              <a:rPr lang="en-US"/>
               <a:t>Once running, they keep working until you manually stop them</a:t>
             </a:r>
           </a:p>
@@ -7962,7 +8115,7 @@
 </p:sld>
 </file>
 
-<file path=ppt/slides/slide15.xml><?xml version="1.0" encoding="utf-8"?>
+<file path=ppt/slides/slide16.xml><?xml version="1.0" encoding="utf-8"?>
 <p:sld xmlns:a="http://schemas.openxmlformats.org/drawingml/2006/main" xmlns:r="http://schemas.openxmlformats.org/officeDocument/2006/relationships" xmlns:p="http://schemas.openxmlformats.org/presentationml/2006/main">
   <p:cSld>
     <p:spTree>
@@ -8031,7 +8184,7 @@
           <a:lstStyle/>
           <a:p>
             <a:r>
-              <a:rPr lang="en-US" dirty="0"/>
+              <a:rPr lang="en-US"/>
               <a:t>Schedulers tested</a:t>
             </a:r>
           </a:p>
@@ -8061,25 +8214,25 @@
           <a:lstStyle/>
           <a:p>
             <a:r>
-              <a:rPr lang="en-US" dirty="0"/>
+              <a:rPr lang="en-US"/>
               <a:t>CFS – Completely Fair Scheduler – The default Linux scheduler</a:t>
             </a:r>
           </a:p>
           <a:p>
             <a:r>
-              <a:rPr lang="en-US" dirty="0"/>
+              <a:rPr lang="en-US"/>
               <a:t>RR – Round Robin – Tasks can run until their time slice expires</a:t>
             </a:r>
           </a:p>
           <a:p>
             <a:r>
-              <a:rPr lang="en-US" dirty="0"/>
+              <a:rPr lang="en-US"/>
               <a:t>FIFO – First in, First out – Tasks run in order and to completion</a:t>
             </a:r>
           </a:p>
           <a:p>
             <a:r>
-              <a:rPr lang="en-US" dirty="0"/>
+              <a:rPr lang="en-US"/>
               <a:t>Prio – Priority Queue – Tasks are given a priority when they're </a:t>
             </a:r>
             <a:r>
@@ -8090,35 +8243,35 @@
           </a:p>
           <a:p>
             <a:r>
-              <a:rPr lang="en-US" dirty="0"/>
+              <a:rPr lang="en-US"/>
               <a:t>Testing was done with</a:t>
             </a:r>
             <a:br>
-              <a:rPr lang="en-US" dirty="0"/>
+              <a:rPr lang="en-US"/>
             </a:br>
             <a:r>
-              <a:rPr lang="en-US" dirty="0"/>
+              <a:rPr lang="en-US"/>
               <a:t>the stress-ng --matrix tool</a:t>
             </a:r>
           </a:p>
           <a:p>
             <a:pPr lvl="1" indent="-228600"/>
             <a:r>
-              <a:rPr lang="en-US" i="0" dirty="0"/>
+              <a:rPr lang="en-US" i="0"/>
               <a:t> - Performs millions of </a:t>
             </a:r>
             <a:br>
-              <a:rPr lang="en-US" i="0" dirty="0"/>
+              <a:rPr lang="en-US" i="0"/>
             </a:br>
             <a:r>
-              <a:rPr lang="en-US" i="0" dirty="0"/>
+              <a:rPr lang="en-US" i="0"/>
               <a:t>floating point operations</a:t>
             </a:r>
           </a:p>
           <a:p>
             <a:pPr lvl="1" indent="-285750"/>
             <a:r>
-              <a:rPr lang="en-US" i="0" dirty="0"/>
+              <a:rPr lang="en-US" i="0"/>
               <a:t> </a:t>
             </a:r>
           </a:p>
@@ -8137,7 +8290,7 @@
 </p:sld>
 </file>
 
-<file path=ppt/slides/slide16.xml><?xml version="1.0" encoding="utf-8"?>
+<file path=ppt/slides/slide17.xml><?xml version="1.0" encoding="utf-8"?>
 <p:sld xmlns:a="http://schemas.openxmlformats.org/drawingml/2006/main" xmlns:r="http://schemas.openxmlformats.org/officeDocument/2006/relationships" xmlns:p="http://schemas.openxmlformats.org/presentationml/2006/main">
   <p:cSld>
     <p:spTree>
@@ -8434,23 +8587,40 @@
           </a:p>
           <a:p>
             <a:r>
-              <a:rPr lang="en-US" dirty="0"/>
+              <a:rPr lang="en-US"/>
               <a:t>A </a:t>
             </a:r>
             <a:r>
-              <a:rPr lang="en-US" dirty="0" err="1"/>
+              <a:rPr lang="en-US" err="1"/>
               <a:t>core.c</a:t>
             </a:r>
             <a:r>
-              <a:rPr lang="en-US" dirty="0"/>
+              <a:rPr lang="en-US"/>
               <a:t> to handle scheduling, interrupts and context switches, calls different scheduler classes files ( in the kernel/sched folder) to see which task to run next. </a:t>
             </a:r>
           </a:p>
           <a:p>
-            <a:endParaRPr lang="en-US" dirty="0"/>
-          </a:p>
-          <a:p>
-            <a:endParaRPr lang="en-US" dirty="0"/>
+            <a:r>
+              <a:rPr lang="en-US"/>
+              <a:t>FCFS and Shortest Job First are not implemented in default </a:t>
+            </a:r>
+            <a:r>
+              <a:rPr lang="en-US" err="1"/>
+              <a:t>linux</a:t>
+            </a:r>
+            <a:r>
+              <a:rPr lang="en-US"/>
+              <a:t> kernel</a:t>
+            </a:r>
+          </a:p>
+          <a:p>
+            <a:pPr marL="0" indent="0">
+              <a:buNone/>
+            </a:pPr>
+            <a:endParaRPr lang="en-US"/>
+          </a:p>
+          <a:p>
+            <a:endParaRPr lang="en-US"/>
           </a:p>
         </p:txBody>
       </p:sp>
@@ -8651,7 +8821,7 @@
           <a:lstStyle/>
           <a:p>
             <a:r>
-              <a:rPr lang="en-US" dirty="0"/>
+              <a:rPr lang="en-US"/>
               <a:t>About the test script for the scheduler: how is efficiency measured? How many processes are run? </a:t>
             </a:r>
           </a:p>
@@ -8839,7 +9009,7 @@
           <a:p>
             <a:pPr algn="ctr"/>
             <a:r>
-              <a:rPr lang="en-US" dirty="0"/>
+              <a:rPr lang="en-US"/>
               <a:t>Algorithm : FCFS</a:t>
             </a:r>
           </a:p>
@@ -8941,7 +9111,7 @@
           <a:p>
             <a:pPr algn="ctr"/>
             <a:r>
-              <a:rPr lang="en-US" dirty="0"/>
+              <a:rPr lang="en-US"/>
               <a:t>Algorithm : Priority</a:t>
             </a:r>
           </a:p>
@@ -9066,7 +9236,7 @@
           <a:p>
             <a:pPr algn="ctr"/>
             <a:r>
-              <a:rPr lang="en-US" dirty="0"/>
+              <a:rPr lang="en-US"/>
               <a:t>Algorithm : RR</a:t>
             </a:r>
           </a:p>

</xml_diff>